<commit_message>
codes zip file updated + presentation draft read
</commit_message>
<xml_diff>
--- a/report/CSE705_Cora_GNN.pptx
+++ b/report/CSE705_Cora_GNN.pptx
@@ -344,24 +344,49 @@
           <a:p>
             <a:r>
               <a:rPr dirty="0"/>
-              <a:t>Suggested timing: 0:40</a:t>
-            </a:r>
-          </a:p>
-          <a:p>
-            <a:endParaRPr dirty="0"/>
-          </a:p>
-          <a:p>
-            <a:r>
-              <a:rPr dirty="0"/>
-              <a:t>Introduce the study as an empirical examination of architecture-dependent </a:t>
+              <a:t>[0:40]  slide 1 of 18</a:t>
+            </a:r>
+          </a:p>
+          <a:p>
+            <a:r>
+              <a:rPr dirty="0"/>
+              <a:t>Good afternoon. My name is Kiarash Ara, and this is joint work with Yiheng Wu at McMaster University.</a:t>
             </a:r>
             <a:r>
               <a:rPr dirty="0" err="1"/>
-              <a:t>oversmoothing</a:t>
-            </a:r>
-            <a:r>
-              <a:rPr dirty="0"/>
-              <a:t>. The central claim is deliberately limited: increasing depth does not generate one universal failure mode. The observed accuracy, geometry, and training dynamics depend on the propagation architecture and on whether information-preserving pathways are present.</a:t>
+              <a:t/>
+            </a:r>
+            <a:r>
+              <a:rPr dirty="0"/>
+              <a:t/>
+            </a:r>
+          </a:p>
+          <a:p>
+            <a:r>
+              <a:rPr dirty="0"/>
+              <a:t>Our project studies what happens to graph neural networks when they get deeper. The short version is this. Depth does not fail in one single way. It fails differently depending on the architecture.</a:t>
+            </a:r>
+            <a:r>
+              <a:rPr dirty="0" err="1"/>
+              <a:t/>
+            </a:r>
+            <a:r>
+              <a:rPr dirty="0"/>
+              <a:t/>
+            </a:r>
+          </a:p>
+          <a:p>
+            <a:r>
+              <a:rPr dirty="0"/>
+              <a:t>We measured that on the Cora citation network, across four architectures, five depths, and ten random seeds. Over the next twenty minutes I will show you how we separated those failure modes, and why accuracy alone cannot do it.</a:t>
+            </a:r>
+            <a:r>
+              <a:rPr dirty="0" err="1"/>
+              <a:t/>
+            </a:r>
+            <a:r>
+              <a:rPr dirty="0"/>
+              <a:t/>
             </a:r>
           </a:p>
           <a:p>
@@ -442,24 +467,77 @@
           <a:p>
             <a:r>
               <a:rPr dirty="0"/>
-              <a:t>Suggested timing: 1:10</a:t>
-            </a:r>
-          </a:p>
-          <a:p>
-            <a:endParaRPr dirty="0"/>
-          </a:p>
-          <a:p>
-            <a:r>
-              <a:rPr dirty="0"/>
-              <a:t>The three capture points separate propagation from optimization. Epoch zero isolates architecture-dependent transformations before parameter learning. GCN and GAT already lose direction and magnitude with increasing depth, while </a:t>
+              <a:t>[1:10]  slide 12 of 18</a:t>
+            </a:r>
+          </a:p>
+          <a:p>
+            <a:r>
+              <a:rPr dirty="0"/>
+              <a:t>Let me now separate what the architecture does from what training does.</a:t>
             </a:r>
             <a:r>
               <a:rPr dirty="0" err="1"/>
-              <a:t>GraphSAGE</a:t>
-            </a:r>
-            <a:r>
-              <a:rPr dirty="0"/>
-              <a:t> mainly loses direction. Checkpoint and final states then reveal what optimization restores, preserves, or destabilizes.</a:t>
+              <a:t/>
+            </a:r>
+            <a:r>
+              <a:rPr dirty="0"/>
+              <a:t/>
+            </a:r>
+          </a:p>
+          <a:p>
+            <a:r>
+              <a:rPr dirty="0"/>
+              <a:t>The epoch-zero capture is taken before any gradient step. The weights are random. So anything we see here is caused by the propagation operator and the initialization, not by learning.</a:t>
+            </a:r>
+            <a:r>
+              <a:rPr dirty="0" err="1"/>
+              <a:t/>
+            </a:r>
+            <a:r>
+              <a:rPr dirty="0"/>
+              <a:t/>
+            </a:r>
+          </a:p>
+          <a:p>
+            <a:r>
+              <a:rPr dirty="0"/>
+              <a:t>At epoch zero, GCN and GAT lose both direction and magnitude as depth increases. Their energy ratio falls by about twelve and ten orders of magnitude by depth thirty-two.</a:t>
+            </a:r>
+            <a:r>
+              <a:rPr dirty="0" err="1"/>
+              <a:t/>
+            </a:r>
+            <a:r>
+              <a:rPr dirty="0"/>
+              <a:t/>
+            </a:r>
+          </a:p>
+          <a:p>
+            <a:r>
+              <a:rPr dirty="0"/>
+              <a:t>GraphSAGE behaves differently. Its MAD collapses, but its energy does not vanish. It settles around nineteen.</a:t>
+            </a:r>
+            <a:r>
+              <a:rPr dirty="0" err="1"/>
+              <a:t/>
+            </a:r>
+            <a:r>
+              <a:rPr dirty="0"/>
+              <a:t/>
+            </a:r>
+          </a:p>
+          <a:p>
+            <a:r>
+              <a:rPr dirty="0"/>
+              <a:t>That is a strange combination, and it is the subject of the next slide. The checkpoint and final captures then tell us what training changed.</a:t>
+            </a:r>
+            <a:r>
+              <a:rPr dirty="0" err="1"/>
+              <a:t/>
+            </a:r>
+            <a:r>
+              <a:rPr dirty="0"/>
+              <a:t/>
             </a:r>
           </a:p>
           <a:p>
@@ -543,16 +621,37 @@
           <a:p>
             <a:r>
               <a:rPr dirty="0"/>
-              <a:t>Suggested timing: 1:10</a:t>
-            </a:r>
-          </a:p>
-          <a:p>
-            <a:endParaRPr dirty="0"/>
-          </a:p>
-          <a:p>
-            <a:r>
-              <a:rPr dirty="0"/>
-              <a:t>Characterize the GCN signature as a contraction–amplification transition. At 32 layers, the selected checkpoint exhibits very low energy through much of the hidden band, followed by a large increase near the output. Nine of ten seeds show the early-band collapse. The representation-level pattern is robust, but attributing it to a particular parameter or gradient mechanism would require additional causal analysis.</a:t>
+              <a:t>[1:10]  slide 14 of 18</a:t>
+            </a:r>
+          </a:p>
+          <a:p>
+            <a:r>
+              <a:rPr dirty="0"/>
+              <a:t>GCN at depth thirty-two does something different again.</a:t>
+            </a:r>
+          </a:p>
+          <a:p>
+            <a:r>
+              <a:rPr dirty="0"/>
+              <a:t>If we look at energy layer by layer at the checkpoint, the early layers have essentially collapsed. Their energy sits below our numerical floor of ten to the minus twelve, typically for the first twenty-two to twenty-eight of the thirty-one measured layers.</a:t>
+            </a:r>
+          </a:p>
+          <a:p>
+            <a:r>
+              <a:rPr dirty="0"/>
+              <a:t>Then, near the output, the energy grows by many orders of magnitude. So the model contracts and then amplifies. Across the whole band the energy ratio spans twenty-six orders of magnitude between seeds.</a:t>
+            </a:r>
+          </a:p>
+          <a:p>
+            <a:r>
+              <a:rPr dirty="0"/>
+              <a:t>Nine of the ten seeds show this pattern, so it is reproducible rather than one unlucky run.</a:t>
+            </a:r>
+          </a:p>
+          <a:p>
+            <a:r>
+              <a:rPr dirty="0"/>
+              <a:t>I want to be careful here. We can see the pattern clearly. We did not record per-layer gradients, so we cannot tell you the parameter-level cause. That is recorded as an open question.</a:t>
             </a:r>
           </a:p>
           <a:p>
@@ -633,32 +732,139 @@
           <a:p>
             <a:r>
               <a:rPr dirty="0"/>
-              <a:t>Suggested timing: 1:05</a:t>
-            </a:r>
-          </a:p>
-          <a:p>
-            <a:endParaRPr dirty="0"/>
-          </a:p>
-          <a:p>
-            <a:r>
-              <a:rPr dirty="0"/>
-              <a:t>Compare interventions at 32 layers. Jumping Knowledge produces the largest tested recovery at 73.13 percent, followed by </a:t>
+              <a:t>[1:05]  slide 15 of 18</a:t>
+            </a:r>
+          </a:p>
+          <a:p>
+            <a:r>
+              <a:rPr dirty="0"/>
+              <a:t>Given all of that, what actually helps?</a:t>
             </a:r>
             <a:r>
               <a:rPr dirty="0" err="1"/>
-              <a:t>PairNorm</a:t>
-            </a:r>
-            <a:r>
-              <a:rPr dirty="0"/>
-              <a:t> at 58.07 percent. Residual connections alone reach 19.25 percent, and the </a:t>
+              <a:t/>
+            </a:r>
+            <a:r>
+              <a:rPr dirty="0"/>
+              <a:t/>
             </a:r>
             <a:r>
               <a:rPr dirty="0" err="1"/>
-              <a:t>PairNorm</a:t>
-            </a:r>
-            <a:r>
-              <a:rPr dirty="0"/>
-              <a:t>-plus-residual configuration reaches 24.36 percent, close to the 24.1 percent unmitigated baseline. These results support mechanism-specific rather than interchangeable mitigation.</a:t>
+              <a:t/>
+            </a:r>
+            <a:r>
+              <a:rPr dirty="0"/>
+              <a:t/>
+            </a:r>
+          </a:p>
+          <a:p>
+            <a:r>
+              <a:rPr dirty="0"/>
+              <a:t>We tested three mitigations on GCN at depth thirty-two, against an unmitigated baseline of twenty-four percent.</a:t>
+            </a:r>
+            <a:r>
+              <a:rPr dirty="0" err="1"/>
+              <a:t/>
+            </a:r>
+            <a:r>
+              <a:rPr dirty="0"/>
+              <a:t/>
+            </a:r>
+            <a:r>
+              <a:rPr dirty="0" err="1"/>
+              <a:t/>
+            </a:r>
+            <a:r>
+              <a:rPr dirty="0"/>
+              <a:t/>
+            </a:r>
+          </a:p>
+          <a:p>
+            <a:r>
+              <a:rPr dirty="0"/>
+              <a:t>Jumping Knowledge is the clear winner at seventy-three percent. It changes the readout rather than the propagation, so the classifier can draw on earlier layers instead of only the deepest one.</a:t>
+            </a:r>
+            <a:r>
+              <a:rPr dirty="0" err="1"/>
+              <a:t/>
+            </a:r>
+            <a:r>
+              <a:rPr dirty="0"/>
+              <a:t/>
+            </a:r>
+            <a:r>
+              <a:rPr dirty="0" err="1"/>
+              <a:t/>
+            </a:r>
+            <a:r>
+              <a:rPr dirty="0"/>
+              <a:t/>
+            </a:r>
+          </a:p>
+          <a:p>
+            <a:r>
+              <a:rPr dirty="0"/>
+              <a:t>PairNorm reaches fifty-eight percent. It works directly on the geometry, rescaling representations so their spread does not shrink with depth.</a:t>
+            </a:r>
+            <a:r>
+              <a:rPr dirty="0" err="1"/>
+              <a:t/>
+            </a:r>
+            <a:r>
+              <a:rPr dirty="0"/>
+              <a:t/>
+            </a:r>
+            <a:r>
+              <a:rPr dirty="0" err="1"/>
+              <a:t/>
+            </a:r>
+            <a:r>
+              <a:rPr dirty="0"/>
+              <a:t/>
+            </a:r>
+          </a:p>
+          <a:p>
+            <a:r>
+              <a:rPr dirty="0"/>
+              <a:t>Residual connections alone reach nineteen percent, which is below the baseline. Combining PairNorm with residual is also worse than PairNorm by itself.</a:t>
+            </a:r>
+            <a:r>
+              <a:rPr dirty="0" err="1"/>
+              <a:t/>
+            </a:r>
+            <a:r>
+              <a:rPr dirty="0"/>
+              <a:t/>
+            </a:r>
+            <a:r>
+              <a:rPr dirty="0" err="1"/>
+              <a:t/>
+            </a:r>
+            <a:r>
+              <a:rPr dirty="0"/>
+              <a:t/>
+            </a:r>
+          </a:p>
+          <a:p>
+            <a:r>
+              <a:rPr dirty="0"/>
+              <a:t>So these are not interchangeable tools. They target different mechanisms, and combining them does not simply add their benefits.</a:t>
+            </a:r>
+            <a:r>
+              <a:rPr dirty="0" err="1"/>
+              <a:t/>
+            </a:r>
+            <a:r>
+              <a:rPr dirty="0"/>
+              <a:t/>
+            </a:r>
+            <a:r>
+              <a:rPr dirty="0" err="1"/>
+              <a:t/>
+            </a:r>
+            <a:r>
+              <a:rPr dirty="0"/>
+              <a:t/>
             </a:r>
           </a:p>
           <a:p>
@@ -739,16 +945,37 @@
           <a:p>
             <a:r>
               <a:rPr dirty="0"/>
-              <a:t>Suggested timing: 1:05</a:t>
-            </a:r>
-          </a:p>
-          <a:p>
-            <a:endParaRPr dirty="0"/>
-          </a:p>
-          <a:p>
-            <a:r>
-              <a:rPr dirty="0"/>
-              <a:t>Interpret GCNII as the constructive contrast. Initial residuals repeatedly reintroduce the projected input, while identity mapping limits destructive transformation across depth. GCNII reaches 83.26 percent mean test accuracy at 32 layers and maintains near-flat geometric trends. This is consistent with information preservation, although the experiment does not identify a unique causal mechanism.</a:t>
+              <a:t>[1:05]  slide 17 of 18</a:t>
+            </a:r>
+          </a:p>
+          <a:p>
+            <a:r>
+              <a:rPr dirty="0"/>
+              <a:t>That brings me back to GCNII, the one architecture that improved with depth.</a:t>
+            </a:r>
+          </a:p>
+          <a:p>
+            <a:r>
+              <a:rPr dirty="0"/>
+              <a:t>GCNII does two things. It reintroduces the original input representation at every layer, and it adds an identity mapping that limits how much each layer can transform its input.</a:t>
+            </a:r>
+          </a:p>
+          <a:p>
+            <a:r>
+              <a:rPr dirty="0"/>
+              <a:t>The outcome is eighty-three point three percent at thirty-two layers. That is its best result, at the greatest depth tested, and with the tightest spread across seeds of any depth.</a:t>
+            </a:r>
+          </a:p>
+          <a:p>
+            <a:r>
+              <a:rPr dirty="0"/>
+              <a:t>Its contraction slope also stays flat, within roughly plus or minus zero point four at every depth, where GCN's runs from about plus one point six to plus two point five.</a:t>
+            </a:r>
+          </a:p>
+          <a:p>
+            <a:r>
+              <a:rPr dirty="0"/>
+              <a:t>This is consistent with the idea that preserving information across layers is what makes depth usable. I want to say clearly that it is consistent with, and not proof of. We did not inspect GCNII's own gradients.</a:t>
             </a:r>
           </a:p>
           <a:p>
@@ -829,24 +1056,91 @@
           <a:p>
             <a:r>
               <a:rPr dirty="0"/>
-              <a:t>Suggested timing: 1:05</a:t>
-            </a:r>
-          </a:p>
-          <a:p>
-            <a:endParaRPr dirty="0"/>
-          </a:p>
-          <a:p>
-            <a:r>
-              <a:rPr dirty="0"/>
-              <a:t>Close with three bounded conclusions. First, depth-related failure is architecture-specific. Second, accuracy must be interpreted with representation geometry. Third, the present evidence is restricted to Cora, a fixed split, and ten seeds, and it does not establish parameter-level causality. The next research step is transfer testing on larger and </a:t>
+              <a:t>[1:05]  slide 18 of 18</a:t>
+            </a:r>
+          </a:p>
+          <a:p>
+            <a:r>
+              <a:rPr dirty="0"/>
+              <a:t>Three conclusions.</a:t>
             </a:r>
             <a:r>
               <a:rPr dirty="0" err="1"/>
-              <a:t>heterophilous</a:t>
-            </a:r>
-            <a:r>
-              <a:rPr dirty="0"/>
-              <a:t> graphs together with direct gradient and parameter diagnostics.</a:t>
+              <a:t/>
+            </a:r>
+            <a:r>
+              <a:rPr dirty="0"/>
+              <a:t/>
+            </a:r>
+          </a:p>
+          <a:p>
+            <a:r>
+              <a:rPr dirty="0"/>
+              <a:t>First, depth-related failure is architecture-specific. Two of our architectures never trained at depth thirty-two. One trained and then developed a contract-then-amplify signature. Treating those as the same phenomenon would be a mistake.</a:t>
+            </a:r>
+            <a:r>
+              <a:rPr dirty="0" err="1"/>
+              <a:t/>
+            </a:r>
+            <a:r>
+              <a:rPr dirty="0"/>
+              <a:t/>
+            </a:r>
+          </a:p>
+          <a:p>
+            <a:r>
+              <a:rPr dirty="0"/>
+              <a:t>Second, accuracy and representation geometry have to be read together, and measured before training as well as after. That is what allowed us to separate a model that never learned from one that learned and then collapsed.</a:t>
+            </a:r>
+            <a:r>
+              <a:rPr dirty="0" err="1"/>
+              <a:t/>
+            </a:r>
+            <a:r>
+              <a:rPr dirty="0"/>
+              <a:t/>
+            </a:r>
+          </a:p>
+          <a:p>
+            <a:r>
+              <a:rPr dirty="0"/>
+              <a:t>Third, the effective mitigation depends on the architecture. Jumping Knowledge transferred to GAT and not to GraphSAGE.</a:t>
+            </a:r>
+            <a:r>
+              <a:rPr dirty="0" err="1"/>
+              <a:t/>
+            </a:r>
+            <a:r>
+              <a:rPr dirty="0"/>
+              <a:t/>
+            </a:r>
+          </a:p>
+          <a:p>
+            <a:r>
+              <a:rPr dirty="0"/>
+              <a:t>On scope, this is one dataset, one split, and ten seeds. We do not claim a universal depth limit. What we think transfers is the method, not the numbers.</a:t>
+            </a:r>
+            <a:r>
+              <a:rPr dirty="0" err="1"/>
+              <a:t/>
+            </a:r>
+            <a:r>
+              <a:rPr dirty="0"/>
+              <a:t/>
+            </a:r>
+          </a:p>
+          <a:p>
+            <a:r>
+              <a:rPr dirty="0"/>
+              <a:t>Thank you. I am happy to take questions.</a:t>
+            </a:r>
+            <a:r>
+              <a:rPr dirty="0" err="1"/>
+              <a:t/>
+            </a:r>
+            <a:r>
+              <a:rPr dirty="0"/>
+              <a:t/>
             </a:r>
           </a:p>
           <a:p>
@@ -927,16 +1221,83 @@
           <a:p>
             <a:r>
               <a:rPr dirty="0"/>
-              <a:t>Suggested timing: 1:05</a:t>
-            </a:r>
-          </a:p>
-          <a:p>
-            <a:endParaRPr dirty="0"/>
-          </a:p>
-          <a:p>
-            <a:r>
-              <a:rPr dirty="0"/>
-              <a:t>State the problem the study is built to solve. A deep model can fail because it never trained, or because it trained and then collapsed. Both produce accuracy near the majority-class floor, so accuracy cannot tell them apart. Separating them requires measuring the representation before training as well as after, which is what the three capture points provide.</a:t>
+              <a:t>[1:05]  slide 3 of 18</a:t>
+            </a:r>
+          </a:p>
+          <a:p>
+            <a:r>
+              <a:rPr dirty="0"/>
+              <a:t>This slide is the reason the project is designed the way it is.</a:t>
+            </a:r>
+            <a:r>
+              <a:rPr dirty="0" err="1"/>
+              <a:t/>
+            </a:r>
+            <a:r>
+              <a:rPr dirty="0"/>
+              <a:t/>
+            </a:r>
+          </a:p>
+          <a:p>
+            <a:r>
+              <a:rPr dirty="0"/>
+              <a:t>Suppose a deep model performs badly. There are two very different explanations.</a:t>
+            </a:r>
+            <a:r>
+              <a:rPr dirty="0" err="1"/>
+              <a:t/>
+            </a:r>
+            <a:r>
+              <a:rPr dirty="0"/>
+              <a:t/>
+            </a:r>
+          </a:p>
+          <a:p>
+            <a:r>
+              <a:rPr dirty="0"/>
+              <a:t>The first is that the model never trained. The optimizer never moved the weights. Whatever the representation looks like, it is what random propagation produced, not what learning produced.</a:t>
+            </a:r>
+            <a:r>
+              <a:rPr dirty="0" err="1"/>
+              <a:t/>
+            </a:r>
+            <a:r>
+              <a:rPr dirty="0"/>
+              <a:t/>
+            </a:r>
+          </a:p>
+          <a:p>
+            <a:r>
+              <a:rPr dirty="0"/>
+              <a:t>The second is that the model did train, and then repeated propagation contracted what it had learned.</a:t>
+            </a:r>
+            <a:r>
+              <a:rPr dirty="0" err="1"/>
+              <a:t/>
+            </a:r>
+            <a:r>
+              <a:rPr dirty="0"/>
+              <a:t/>
+            </a:r>
+          </a:p>
+          <a:p>
+            <a:r>
+              <a:rPr dirty="0"/>
+              <a:t>Here is the difficulty. Both of these end up at roughly the same accuracy, near the majority-class floor. If you only look at the final accuracy number, the two are indistinguishable.</a:t>
+            </a:r>
+            <a:r>
+              <a:rPr dirty="0" err="1"/>
+              <a:t/>
+            </a:r>
+            <a:r>
+              <a:rPr dirty="0"/>
+              <a:t/>
+            </a:r>
+          </a:p>
+          <a:p>
+            <a:r>
+              <a:rPr dirty="0"/>
+              <a:t>The only way to tell them apart is to look inside the model, and to look before training as well as after. That is exactly what our measurement design does.</a:t>
             </a:r>
             <a:r>
               <a:rPr dirty="0" err="1"/>
@@ -1028,16 +1389,43 @@
           <a:p>
             <a:r>
               <a:rPr dirty="0"/>
-              <a:t>Suggested timing: 1:30</a:t>
-            </a:r>
-          </a:p>
-          <a:p>
-            <a:endParaRPr dirty="0"/>
-          </a:p>
-          <a:p>
-            <a:r>
-              <a:rPr dirty="0"/>
-              <a:t>This is the study’s central negative result. At depth 32 GraphSAGE and GAT do not train at all: the training loss never leaves ln 7, the uninformed floor, moving only 0.01 to 0.02 nats; early stopping exhausts its patience almost immediately, at 101 to 168 epochs against GCN’s 315 to 883; and the checkpoint MAD is indistinguishable from the epoch-0 MAD. None of the three is computed from the others, which is what makes their agreement convergence rather than circularity. Attributing this failure to oversmoothing would be incorrect, because nothing was learned to oversmooth.</a:t>
+              <a:t>[1:30]  slide 11 of 18</a:t>
+            </a:r>
+          </a:p>
+          <a:p>
+            <a:r>
+              <a:rPr dirty="0"/>
+              <a:t>This is the central result of the project. At depth thirty-two, GraphSAGE and GAT do not train at all.</a:t>
+            </a:r>
+          </a:p>
+          <a:p>
+            <a:r>
+              <a:rPr dirty="0"/>
+              <a:t>The number on the left is the natural logarithm of seven, about one point nine five. That is the cross-entropy loss of a model that outputs a uniform guess over seven classes. It is the loss of knowing nothing.</a:t>
+            </a:r>
+          </a:p>
+          <a:p>
+            <a:r>
+              <a:rPr dirty="0"/>
+              <a:t>GraphSAGE bottoms out at one point nine three. GAT at one point nine four. That is a movement of one or two hundredths of a nat. In practical terms, the loss does not move.</a:t>
+            </a:r>
+          </a:p>
+          <a:p>
+            <a:r>
+              <a:rPr dirty="0"/>
+              <a:t>The second signal is early stopping. We allow one hundred epochs of patience. GraphSAGE and GAT exhaust it almost immediately, between one hundred and one hundred and sixty-eight epochs. GCN, by comparison, runs for three hundred to nearly nine hundred.</a:t>
+            </a:r>
+          </a:p>
+          <a:p>
+            <a:r>
+              <a:rPr dirty="0"/>
+              <a:t>The third signal is the representation itself. Their MAD at the checkpoint is the same as their MAD before training started.</a:t>
+            </a:r>
+          </a:p>
+          <a:p>
+            <a:r>
+              <a:rPr dirty="0"/>
+              <a:t>Three measurements, none of them computed from the others, all saying the same thing. The weights never moved. So calling this oversmoothing would be wrong. Nothing was learned, so there was nothing to oversmooth.</a:t>
             </a:r>
           </a:p>
           <a:p>
@@ -1118,16 +1506,123 @@
           <a:p>
             <a:r>
               <a:rPr dirty="0"/>
-              <a:t>Suggested timing: 1:20</a:t>
-            </a:r>
-          </a:p>
-          <a:p>
-            <a:endParaRPr dirty="0"/>
-          </a:p>
-          <a:p>
-            <a:r>
-              <a:rPr dirty="0"/>
-              <a:t>Explain the metric disagreement rather than only reporting it. A singular-value decomposition at depth 16, over three seeds, shows GraphSAGE’s representation is exactly rank-1, and its dominant direction is the constant vector at cosine 1.0000, against 0.9512 for the square-root-degree direction. Because Cora’s degrees range from 2 to 169, the augmented Laplacian’s null space is the square-root-degree direction, not the constant vector. GraphSAGE therefore collapses onto a direction on which Dirichlet energy is not zero, which is why MAD reaches zero while energy plateaus near 19.</a:t>
+              <a:t>[1:20]  slide 13 of 18</a:t>
+            </a:r>
+          </a:p>
+          <a:p>
+            <a:r>
+              <a:rPr dirty="0"/>
+              <a:t>So why do GraphSAGE's two metrics disagree?</a:t>
+            </a:r>
+            <a:r>
+              <a:rPr dirty="0" err="1"/>
+              <a:t/>
+            </a:r>
+            <a:r>
+              <a:rPr dirty="0"/>
+              <a:t/>
+            </a:r>
+            <a:r>
+              <a:rPr dirty="0" err="1"/>
+              <a:t/>
+            </a:r>
+            <a:r>
+              <a:rPr dirty="0"/>
+              <a:t/>
+            </a:r>
+          </a:p>
+          <a:p>
+            <a:r>
+              <a:rPr dirty="0"/>
+              <a:t>We ran a singular value decomposition on its representations at depth sixteen, across three seeds.</a:t>
+            </a:r>
+            <a:r>
+              <a:rPr dirty="0" err="1"/>
+              <a:t/>
+            </a:r>
+            <a:r>
+              <a:rPr dirty="0"/>
+              <a:t/>
+            </a:r>
+            <a:r>
+              <a:rPr dirty="0" err="1"/>
+              <a:t/>
+            </a:r>
+            <a:r>
+              <a:rPr dirty="0"/>
+              <a:t/>
+            </a:r>
+          </a:p>
+          <a:p>
+            <a:r>
+              <a:rPr dirty="0"/>
+              <a:t>The result is that the representation is exactly rank one. The top singular value carries the entire energy, a fraction of one point zero zero zero zero. Every node lies on a single line.</a:t>
+            </a:r>
+            <a:r>
+              <a:rPr dirty="0" err="1"/>
+              <a:t/>
+            </a:r>
+            <a:r>
+              <a:rPr dirty="0"/>
+              <a:t/>
+            </a:r>
+            <a:r>
+              <a:rPr dirty="0" err="1"/>
+              <a:t/>
+            </a:r>
+            <a:r>
+              <a:rPr dirty="0"/>
+              <a:t/>
+            </a:r>
+          </a:p>
+          <a:p>
+            <a:r>
+              <a:rPr dirty="0"/>
+              <a:t>The question is which line. Its top singular vector matches the constant direction with cosine one point zero zero zero zero. Against the square root of degree direction it is zero point nine five.</a:t>
+            </a:r>
+            <a:r>
+              <a:rPr dirty="0" err="1"/>
+              <a:t/>
+            </a:r>
+            <a:r>
+              <a:rPr dirty="0"/>
+              <a:t/>
+            </a:r>
+            <a:r>
+              <a:rPr dirty="0" err="1"/>
+              <a:t/>
+            </a:r>
+            <a:r>
+              <a:rPr dirty="0"/>
+              <a:t/>
+            </a:r>
+          </a:p>
+          <a:p>
+            <a:r>
+              <a:rPr dirty="0"/>
+              <a:t>Here is why that matters. Dirichlet energy is zero only on the null space of the graph Laplacian. On Cora, node degrees range from two to one hundred and sixty-nine. Because the graph is irregular, that null space is the square root of degree direction, not the constant vector.</a:t>
+            </a:r>
+            <a:r>
+              <a:rPr dirty="0" err="1"/>
+              <a:t/>
+            </a:r>
+            <a:r>
+              <a:rPr dirty="0"/>
+              <a:t/>
+            </a:r>
+            <a:r>
+              <a:rPr dirty="0" err="1"/>
+              <a:t/>
+            </a:r>
+            <a:r>
+              <a:rPr dirty="0"/>
+              <a:t/>
+            </a:r>
+          </a:p>
+          <a:p>
+            <a:r>
+              <a:rPr dirty="0"/>
+              <a:t>So GraphSAGE collapses onto a direction where energy is not zero. Its representations align completely, MAD goes to zero, and the energy stays high. Both metrics are correct. They are answering different questions.</a:t>
             </a:r>
             <a:r>
               <a:rPr dirty="0" err="1"/>
@@ -1227,16 +1722,101 @@
           <a:p>
             <a:r>
               <a:rPr dirty="0"/>
-              <a:t>Suggested timing: 1:15</a:t>
-            </a:r>
-          </a:p>
-          <a:p>
-            <a:endParaRPr dirty="0"/>
-          </a:p>
-          <a:p>
-            <a:r>
-              <a:rPr dirty="0"/>
-              <a:t>Report the transfer experiment. Jumping Knowledge was selected on GCN and then run on GraphSAGE and GAT across the full depth grid, ten seeds each. On GAT it recovers to 72.09 percent, within one standard deviation of GCN’s 73.13, and macro-F1 recovers to essentially the same value. On GraphSAGE it reaches only 40.47 percent with macro-F1 0.2611. All ten seeds sit above the majority-class floor, so the gain is real, but it is roughly a third of what the same mitigation achieves elsewhere and is not spread evenly across classes. The effective mitigation therefore depends on the architecture, not only on the depth.</a:t>
+              <a:t>[1:15]  slide 16 of 18</a:t>
+            </a:r>
+          </a:p>
+          <a:p>
+            <a:r>
+              <a:rPr dirty="0"/>
+              <a:t>Jumping Knowledge won on GCN, so we carried it to the other two architectures. Same mitigation, same protocol, ten seeds each.</a:t>
+            </a:r>
+            <a:r>
+              <a:rPr dirty="0" err="1"/>
+              <a:t/>
+            </a:r>
+            <a:r>
+              <a:rPr dirty="0"/>
+              <a:t/>
+            </a:r>
+            <a:r>
+              <a:rPr dirty="0" err="1"/>
+              <a:t/>
+            </a:r>
+            <a:r>
+              <a:rPr dirty="0"/>
+              <a:t/>
+            </a:r>
+          </a:p>
+          <a:p>
+            <a:r>
+              <a:rPr dirty="0"/>
+              <a:t>On GAT it works. Seventy-two percent, essentially matching GCN's seventy-three. The macro-F1 values are almost identical as well.</a:t>
+            </a:r>
+            <a:r>
+              <a:rPr dirty="0" err="1"/>
+              <a:t/>
+            </a:r>
+            <a:r>
+              <a:rPr dirty="0"/>
+              <a:t/>
+            </a:r>
+            <a:r>
+              <a:rPr dirty="0" err="1"/>
+              <a:t/>
+            </a:r>
+            <a:r>
+              <a:rPr dirty="0"/>
+              <a:t/>
+            </a:r>
+          </a:p>
+          <a:p>
+            <a:r>
+              <a:rPr dirty="0"/>
+              <a:t>On GraphSAGE it does not. It reaches forty percent. That is a real improvement, and all ten seeds sit above the majority-class floor, so I do not want to dismiss it. But it is about a third of what the same mitigation achieves on the other two.</a:t>
+            </a:r>
+            <a:r>
+              <a:rPr dirty="0" err="1"/>
+              <a:t/>
+            </a:r>
+            <a:r>
+              <a:rPr dirty="0"/>
+              <a:t/>
+            </a:r>
+            <a:r>
+              <a:rPr dirty="0" err="1"/>
+              <a:t/>
+            </a:r>
+            <a:r>
+              <a:rPr dirty="0"/>
+              <a:t/>
+            </a:r>
+          </a:p>
+          <a:p>
+            <a:r>
+              <a:rPr dirty="0"/>
+              <a:t>The macro-F1 tells you more. Zero point two six, against zero point seven two for the other two. So even the accuracy it does recover is not spread evenly across the seven classes.</a:t>
+            </a:r>
+            <a:r>
+              <a:rPr dirty="0" err="1"/>
+              <a:t/>
+            </a:r>
+            <a:r>
+              <a:rPr dirty="0"/>
+              <a:t/>
+            </a:r>
+            <a:r>
+              <a:rPr dirty="0" err="1"/>
+              <a:t/>
+            </a:r>
+            <a:r>
+              <a:rPr dirty="0"/>
+              <a:t/>
+            </a:r>
+          </a:p>
+          <a:p>
+            <a:r>
+              <a:rPr dirty="0"/>
+              <a:t>The conclusion is that you cannot choose a mitigation from the depth alone. It depends on which architecture you are trying to fix.</a:t>
             </a:r>
             <a:r>
               <a:rPr dirty="0" err="1"/>
@@ -1333,51 +1913,77 @@
           <a:p>
             <a:r>
               <a:rPr dirty="0"/>
-              <a:t>Suggested timing: 1:00</a:t>
-            </a:r>
-          </a:p>
-          <a:p>
-            <a:endParaRPr dirty="0"/>
-          </a:p>
-          <a:p>
-            <a:r>
-              <a:rPr dirty="0"/>
-              <a:t>Motivate the analysis through the depth–expressivity trade-off. Each layer increases graph context, but repeated aggregation can contract variation in the hidden state. The equation is shown for the GCN case as a representative operator, not as a universal description of </a:t>
+              <a:t>[1:00]  slide 2 of 18</a:t>
+            </a:r>
+          </a:p>
+          <a:p>
+            <a:r>
+              <a:rPr dirty="0"/>
+              <a:t>Let me start with why depth matters at all.</a:t>
             </a:r>
             <a:r>
               <a:rPr dirty="0" err="1"/>
-              <a:t>GraphSAGE</a:t>
-            </a:r>
-            <a:r>
-              <a:rPr dirty="0"/>
-              <a:t>, GAT, or GCNII. The toy embedding panel is illustrative only; the subsequent Cora experiments provide the evidence.</a:t>
-            </a:r>
-          </a:p>
-          <a:p>
-            <a:endParaRPr dirty="0"/>
-          </a:p>
-          <a:p>
-            <a:r>
-              <a:rPr dirty="0"/>
-              <a:t>[Sources]</a:t>
-            </a:r>
-          </a:p>
-          <a:p>
-            <a:r>
-              <a:rPr dirty="0"/>
-              <a:t>- report/CSE705_GNN_ARAK_WU1261.ipynb — Sections 1.3 and 2.2</a:t>
-            </a:r>
-          </a:p>
-          <a:p>
-            <a:r>
-              <a:rPr dirty="0"/>
-              <a:t>- figures/karate_club_collapse.pdf</a:t>
-            </a:r>
-          </a:p>
-          <a:p>
-            <a:r>
-              <a:rPr dirty="0"/>
-              <a:t>[/Sources]</a:t>
+              <a:t/>
+            </a:r>
+            <a:r>
+              <a:rPr dirty="0"/>
+              <a:t/>
+            </a:r>
+          </a:p>
+          <a:p>
+            <a:r>
+              <a:rPr dirty="0"/>
+              <a:t>A graph neural network passes messages between connected nodes. Each layer lets a node see one hop further into the graph. So depth is how the model widens its view.</a:t>
+            </a:r>
+            <a:r>
+              <a:rPr dirty="0" err="1"/>
+              <a:t/>
+            </a:r>
+            <a:r>
+              <a:rPr dirty="0"/>
+              <a:t/>
+            </a:r>
+          </a:p>
+          <a:p>
+            <a:r>
+              <a:rPr dirty="0"/>
+              <a:t>For a graph convolutional network, one layer looks like the equation on the screen. We multiply by a normalized propagation operator, multiply by a weight matrix, and apply a nonlinearity.</a:t>
+            </a:r>
+            <a:r>
+              <a:rPr dirty="0" err="1"/>
+              <a:t/>
+            </a:r>
+            <a:r>
+              <a:rPr dirty="0"/>
+              <a:t/>
+            </a:r>
+          </a:p>
+          <a:p>
+            <a:r>
+              <a:rPr dirty="0"/>
+              <a:t>The problem is that applying that operator again and again pulls node representations toward one another. Nodes that started out different become similar.</a:t>
+            </a:r>
+            <a:r>
+              <a:rPr dirty="0" err="1"/>
+              <a:t/>
+            </a:r>
+            <a:r>
+              <a:rPr dirty="0"/>
+              <a:t/>
+            </a:r>
+          </a:p>
+          <a:p>
+            <a:r>
+              <a:rPr dirty="0"/>
+              <a:t>The panel on the left illustrates that on a small toy graph. It is only an illustration. Every claim I make after this slide comes from measurements on Cora. The question we asked is whether that contraction looks the same for every architecture.</a:t>
+            </a:r>
+            <a:r>
+              <a:rPr dirty="0" err="1"/>
+              <a:t/>
+            </a:r>
+            <a:r>
+              <a:rPr dirty="0"/>
+              <a:t/>
             </a:r>
           </a:p>
         </p:txBody>
@@ -1455,24 +2061,63 @@
           <a:p>
             <a:r>
               <a:rPr dirty="0"/>
-              <a:t>Suggested timing: 1:00</a:t>
-            </a:r>
-          </a:p>
-          <a:p>
-            <a:endParaRPr dirty="0"/>
-          </a:p>
-          <a:p>
-            <a:r>
-              <a:rPr dirty="0"/>
-              <a:t>State the primary question and the three hypotheses before presenting results. H1 concerns predictive behavior, H2 concerns representation geometry, and H3 concerns intervention specificity. These hypotheses prevent the discussion from reducing </a:t>
+              <a:t>[1:00]  slide 4 of 18</a:t>
+            </a:r>
+          </a:p>
+          <a:p>
+            <a:r>
+              <a:rPr dirty="0"/>
+              <a:t>So the primary question is this. How does depth change both predictive behavior and the geometry of the hidden representations?</a:t>
             </a:r>
             <a:r>
               <a:rPr dirty="0" err="1"/>
-              <a:t>oversmoothing</a:t>
-            </a:r>
-            <a:r>
-              <a:rPr dirty="0"/>
-              <a:t> to a single accuracy curve and make clear what evidence would distinguish architectures.</a:t>
+              <a:t/>
+            </a:r>
+            <a:r>
+              <a:rPr dirty="0"/>
+              <a:t/>
+            </a:r>
+          </a:p>
+          <a:p>
+            <a:r>
+              <a:rPr dirty="0"/>
+              <a:t>We compare across two to thirty-two layers, holding the data and the training protocol fixed, so that depth is the only thing that moves.</a:t>
+            </a:r>
+            <a:r>
+              <a:rPr dirty="0" err="1"/>
+              <a:t/>
+            </a:r>
+            <a:r>
+              <a:rPr dirty="0"/>
+              <a:t/>
+            </a:r>
+          </a:p>
+          <a:p>
+            <a:r>
+              <a:rPr dirty="0"/>
+              <a:t>We test three hypotheses. The first is that accuracy degrades unevenly across architectures. The second is that geometric collapse is not the same thing in every model. The third is that the mitigation which works depends on which failure mechanism is actually present.</a:t>
+            </a:r>
+            <a:r>
+              <a:rPr dirty="0" err="1"/>
+              <a:t/>
+            </a:r>
+            <a:r>
+              <a:rPr dirty="0"/>
+              <a:t/>
+            </a:r>
+          </a:p>
+          <a:p>
+            <a:r>
+              <a:rPr dirty="0"/>
+              <a:t>These are stated in advance. They tell you what would count as a result before you see any of the numbers.</a:t>
+            </a:r>
+            <a:r>
+              <a:rPr dirty="0" err="1"/>
+              <a:t/>
+            </a:r>
+            <a:r>
+              <a:rPr dirty="0"/>
+              <a:t/>
             </a:r>
           </a:p>
           <a:p>
@@ -1553,16 +2198,31 @@
           <a:p>
             <a:r>
               <a:rPr dirty="0"/>
-              <a:t>Suggested timing: 0:55</a:t>
-            </a:r>
-          </a:p>
-          <a:p>
-            <a:endParaRPr dirty="0"/>
-          </a:p>
-          <a:p>
-            <a:r>
-              <a:rPr dirty="0"/>
-              <a:t>Define the task and the controlled benchmark. The graph, node features, labels, and Planetoid split remain fixed. Consequently, the principal experimental factors are architecture, depth, seed, and mitigation. The training set contains only 140 labeled nodes, which makes representation quality consequential without changing the evaluation protocol across runs.</a:t>
+              <a:t>[0:55]  slide 5 of 18</a:t>
+            </a:r>
+          </a:p>
+          <a:p>
+            <a:r>
+              <a:rPr dirty="0"/>
+              <a:t>All experiments run on Cora. It is a citation network. Each node is a scientific paper, and each edge is a citation between two papers.</a:t>
+            </a:r>
+          </a:p>
+          <a:p>
+            <a:r>
+              <a:rPr dirty="0"/>
+              <a:t>There are two thousand seven hundred and eight papers, five thousand two hundred and seventy-eight citation links, and seven research topics to predict. Each paper is described by one thousand four hundred and thirty-three binary word features.</a:t>
+            </a:r>
+          </a:p>
+          <a:p>
+            <a:r>
+              <a:rPr dirty="0"/>
+              <a:t>We use the standard public split. One hundred and forty labeled nodes for training, five hundred for validation, and one thousand for testing.</a:t>
+            </a:r>
+          </a:p>
+          <a:p>
+            <a:r>
+              <a:rPr dirty="0"/>
+              <a:t>One hundred and forty labels is a very small number. That is deliberate. It makes the quality of the learned representation matter.</a:t>
             </a:r>
           </a:p>
           <a:p>
@@ -1643,24 +2303,77 @@
           <a:p>
             <a:r>
               <a:rPr dirty="0"/>
-              <a:t>Suggested timing: 1:00</a:t>
-            </a:r>
-          </a:p>
-          <a:p>
-            <a:endParaRPr dirty="0"/>
-          </a:p>
-          <a:p>
-            <a:r>
-              <a:rPr dirty="0"/>
-              <a:t>Treat the four models as controlled architectural contrasts. GCN supplies the canonical normalized propagation baseline. </a:t>
+              <a:t>[1:00]  slide 6 of 18</a:t>
+            </a:r>
+          </a:p>
+          <a:p>
+            <a:r>
+              <a:rPr dirty="0"/>
+              <a:t>We compare four architectures, chosen because they aggregate information in genuinely different ways.</a:t>
             </a:r>
             <a:r>
               <a:rPr dirty="0" err="1"/>
-              <a:t>GraphSAGE</a:t>
-            </a:r>
-            <a:r>
-              <a:rPr dirty="0"/>
-              <a:t> changes the combination of self and neighborhood information. GAT introduces learned neighbor weights. GCNII is not merely another baseline; its initial residual and identity mapping explicitly address trainability and information preservation at depth.</a:t>
+              <a:t/>
+            </a:r>
+            <a:r>
+              <a:rPr dirty="0"/>
+              <a:t/>
+            </a:r>
+          </a:p>
+          <a:p>
+            <a:r>
+              <a:rPr dirty="0"/>
+              <a:t>GCN uses symmetric normalized propagation. It is our reference point for depth-induced contraction.</a:t>
+            </a:r>
+            <a:r>
+              <a:rPr dirty="0" err="1"/>
+              <a:t/>
+            </a:r>
+            <a:r>
+              <a:rPr dirty="0"/>
+              <a:t/>
+            </a:r>
+          </a:p>
+          <a:p>
+            <a:r>
+              <a:rPr dirty="0"/>
+              <a:t>GraphSAGE keeps the node's own features in a separate term from the neighborhood average, so self information and neighbor information are handled separately.</a:t>
+            </a:r>
+            <a:r>
+              <a:rPr dirty="0" err="1"/>
+              <a:t/>
+            </a:r>
+            <a:r>
+              <a:rPr dirty="0"/>
+              <a:t/>
+            </a:r>
+          </a:p>
+          <a:p>
+            <a:r>
+              <a:rPr dirty="0"/>
+              <a:t>GAT learns attention weights over neighbors. That lets us ask whether adaptive weighting delays collapse.</a:t>
+            </a:r>
+            <a:r>
+              <a:rPr dirty="0" err="1"/>
+              <a:t/>
+            </a:r>
+            <a:r>
+              <a:rPr dirty="0"/>
+              <a:t/>
+            </a:r>
+          </a:p>
+          <a:p>
+            <a:r>
+              <a:rPr dirty="0"/>
+              <a:t>GCNII is different in kind. It reintroduces the initial representation at every layer and adds an identity mapping. It was designed specifically to make depth work. So GCNII is not simply a fourth baseline. It is a control that tells us what happens when information is deliberately preserved.</a:t>
+            </a:r>
+            <a:r>
+              <a:rPr dirty="0" err="1"/>
+              <a:t/>
+            </a:r>
+            <a:r>
+              <a:rPr dirty="0"/>
+              <a:t/>
             </a:r>
           </a:p>
           <a:p>
@@ -1741,16 +2454,37 @@
           <a:p>
             <a:r>
               <a:rPr dirty="0"/>
-              <a:t>Suggested timing: 1:05</a:t>
-            </a:r>
-          </a:p>
-          <a:p>
-            <a:endParaRPr dirty="0"/>
-          </a:p>
-          <a:p>
-            <a:r>
-              <a:rPr dirty="0"/>
-              <a:t>Describe the protocol as three linked analyses. The factorial sweep estimates depth trends across four architectures and five depths using ten independent seeds. Representation diagnostics are captured before learning, at the validation-selected checkpoint, and at the final epoch. The intervention analysis then tests whether common mitigation strategies recover the deep regime under the same evaluation contract.</a:t>
+              <a:t>[1:05]  slide 7 of 18</a:t>
+            </a:r>
+          </a:p>
+          <a:p>
+            <a:r>
+              <a:rPr dirty="0"/>
+              <a:t>The experimental design has three parts.</a:t>
+            </a:r>
+          </a:p>
+          <a:p>
+            <a:r>
+              <a:rPr dirty="0"/>
+              <a:t>The first is the depth sweep. Four architectures, five depths from two to thirty-two, and ten independent random seeds for every configuration. Every number I report is a mean over ten seeds.</a:t>
+            </a:r>
+          </a:p>
+          <a:p>
+            <a:r>
+              <a:rPr dirty="0"/>
+              <a:t>The second is the diagnostics. Alongside test accuracy we record two representation measures, mean average distance and Dirichlet energy. We record them at three points in every run: at initialization before any gradient step, at the checkpoint we actually report, and at the final epoch.</a:t>
+            </a:r>
+          </a:p>
+          <a:p>
+            <a:r>
+              <a:rPr dirty="0"/>
+              <a:t>The third is the interventions. We test residual connections, PairNorm, and Jumping Knowledge on top of GCN, and we treat GCNII as the architectural control.</a:t>
+            </a:r>
+          </a:p>
+          <a:p>
+            <a:r>
+              <a:rPr dirty="0"/>
+              <a:t>In total this is five hundred and thirty-four training runs, and every figure in the report regenerates from the stored records.</a:t>
             </a:r>
           </a:p>
           <a:p>
@@ -1831,20 +2565,61 @@
           <a:p>
             <a:r>
               <a:rPr dirty="0"/>
-              <a:t>Suggested timing: 1:15</a:t>
-            </a:r>
-          </a:p>
-          <a:p>
+              <a:t>[1:15]  slide 8 of 18</a:t>
+            </a:r>
+          </a:p>
+          <a:p>
+            <a:r>
+              <a:rPr dirty="0"/>
+              <a:t>These are the two instruments. The important thing is that they do not measure the same property.</a:t>
+            </a:r>
+            <a:r>
+              <a:rPr lang="en-US" dirty="0"/>
+              <a:t/>
+            </a:r>
             <a:endParaRPr dirty="0"/>
           </a:p>
           <a:p>
             <a:r>
               <a:rPr dirty="0"/>
-              <a:t>Define both instruments precisely. MAD is the mean non-zero cosine distance between node embeddings and is invariant to positive rescaling. Dirichlet energy is computed per feature dimension on one fixed augmented Cora graph, with degree-normalized endpoints; it changes quadratically with representation magnitude. Their disagreement is therefore interpretable rather than contradictory</a:t>
+              <a:t>Mean average distance, which I will call MAD, is built from cosine distance between node representations. It asks whether nodes point in the same direction. It is scale invariant. If you multiply every node representation by a positive number, MAD does not change.</a:t>
             </a:r>
             <a:r>
               <a:rPr lang="en-US" dirty="0"/>
-              <a:t>.</a:t>
+              <a:t/>
+            </a:r>
+            <a:endParaRPr dirty="0"/>
+          </a:p>
+          <a:p>
+            <a:r>
+              <a:rPr dirty="0"/>
+              <a:t>Dirichlet energy asks something different. It measures how much representations differ across the edges of the graph, with degree normalization. It is quadratic in magnitude. If you scale the representation by c, the energy scales by c squared.</a:t>
+            </a:r>
+            <a:r>
+              <a:rPr lang="en-US" dirty="0"/>
+              <a:t/>
+            </a:r>
+            <a:endParaRPr dirty="0"/>
+          </a:p>
+          <a:p>
+            <a:r>
+              <a:rPr dirty="0"/>
+              <a:t>So one metric sees direction and ignores size. The other sees both.</a:t>
+            </a:r>
+            <a:r>
+              <a:rPr lang="en-US" dirty="0"/>
+              <a:t/>
+            </a:r>
+            <a:endParaRPr dirty="0"/>
+          </a:p>
+          <a:p>
+            <a:r>
+              <a:rPr dirty="0"/>
+              <a:t>That difference is deliberate. It means that when the two metrics disagree, the disagreement is informative rather than contradictory. Later in the talk I will show you a case where they disagree completely, and where that disagreement is the finding.</a:t>
+            </a:r>
+            <a:r>
+              <a:rPr lang="en-US" dirty="0"/>
+              <a:t/>
             </a:r>
             <a:endParaRPr dirty="0"/>
           </a:p>
@@ -1923,16 +2698,37 @@
           <a:p>
             <a:r>
               <a:rPr dirty="0"/>
-              <a:t>Suggested timing: 1:15</a:t>
-            </a:r>
-          </a:p>
-          <a:p>
-            <a:endParaRPr dirty="0"/>
-          </a:p>
-          <a:p>
-            <a:r>
-              <a:rPr dirty="0"/>
-              <a:t>Report the first result at two levels. Conventional architectures peak in the shallow regime and deteriorate beyond four layers. In contrast, GCNII attains 83.26 percent mean test accuracy at 32 layers. The appropriate inference is not that depth is beneficial in general, but that the effect of depth is conditional on the architecture used to propagate and preserve information.</a:t>
+              <a:t>[1:15]  slide 9 of 18</a:t>
+            </a:r>
+          </a:p>
+          <a:p>
+            <a:r>
+              <a:rPr dirty="0"/>
+              <a:t>Here is the first result.</a:t>
+            </a:r>
+          </a:p>
+          <a:p>
+            <a:r>
+              <a:rPr dirty="0"/>
+              <a:t>All three conventional architectures peak at depth two. By depth four they have already lost between four and eight accuracy points. Beyond that they fall steeply.</a:t>
+            </a:r>
+          </a:p>
+          <a:p>
+            <a:r>
+              <a:rPr dirty="0"/>
+              <a:t>At depth thirty-two, all three sit below thirty-one point nine percent. That number is the majority-class floor. It is the accuracy you get by ignoring the input entirely and always predicting the most common class. So these deep models are worse than a rule that does not look at the data at all.</a:t>
+            </a:r>
+          </a:p>
+          <a:p>
+            <a:r>
+              <a:rPr dirty="0"/>
+              <a:t>Macro-F1 is worse still. GCN reaches zero point two one, GraphSAGE zero point zero five, GAT zero point zero five. That tells us the predictions concentrate onto a few classes rather than spreading errors evenly.</a:t>
+            </a:r>
+          </a:p>
+          <a:p>
+            <a:r>
+              <a:rPr dirty="0"/>
+              <a:t>And then there is GCNII, on the right: eighty-three point three percent at thirty-two layers. That is its best result, at the greatest depth we tested. So depth is not uniformly harmful. It depends on the architecture.</a:t>
             </a:r>
           </a:p>
           <a:p>
@@ -2013,32 +2809,117 @@
           <a:p>
             <a:r>
               <a:rPr dirty="0"/>
-              <a:t>Suggested timing: 1:05</a:t>
-            </a:r>
-          </a:p>
-          <a:p>
-            <a:endParaRPr dirty="0"/>
-          </a:p>
-          <a:p>
-            <a:r>
-              <a:rPr dirty="0"/>
-              <a:t>Use MAD to reject a single-mechanism account of deep failure. </a:t>
+              <a:t>[1:05]  slide 10 of 18</a:t>
+            </a:r>
+          </a:p>
+          <a:p>
+            <a:r>
+              <a:rPr dirty="0"/>
+              <a:t>Now the same runs, viewed through geometry rather than accuracy.</a:t>
             </a:r>
             <a:r>
               <a:rPr dirty="0" err="1"/>
-              <a:t>GraphSAGE</a:t>
-            </a:r>
-            <a:r>
-              <a:rPr dirty="0"/>
-              <a:t> and GAT approach directional collapse at high depth, whereas GCN retains greater angular diversity despite losing predictive accuracy. Consequently, similar accuracy endpoints do not establish equivalent internal states, and accuracy alone cannot diagnose </a:t>
+              <a:t/>
+            </a:r>
+            <a:r>
+              <a:rPr dirty="0"/>
+              <a:t/>
             </a:r>
             <a:r>
               <a:rPr dirty="0" err="1"/>
-              <a:t>oversmoothing</a:t>
-            </a:r>
-            <a:r>
-              <a:rPr dirty="0"/>
-              <a:t>.</a:t>
+              <a:t/>
+            </a:r>
+            <a:r>
+              <a:rPr dirty="0"/>
+              <a:t/>
+            </a:r>
+          </a:p>
+          <a:p>
+            <a:r>
+              <a:rPr dirty="0"/>
+              <a:t>This is MAD against depth. GraphSAGE and GAT fall to essentially zero. Their node representations end up pointing in the same direction. That is directional collapse.</a:t>
+            </a:r>
+            <a:r>
+              <a:rPr dirty="0" err="1"/>
+              <a:t/>
+            </a:r>
+            <a:r>
+              <a:rPr dirty="0"/>
+              <a:t/>
+            </a:r>
+            <a:r>
+              <a:rPr dirty="0" err="1"/>
+              <a:t/>
+            </a:r>
+            <a:r>
+              <a:rPr dirty="0"/>
+              <a:t/>
+            </a:r>
+          </a:p>
+          <a:p>
+            <a:r>
+              <a:rPr dirty="0"/>
+              <a:t>GCN does not. It holds around zero point one eight even at thirty-two layers.</a:t>
+            </a:r>
+            <a:r>
+              <a:rPr dirty="0" err="1"/>
+              <a:t/>
+            </a:r>
+            <a:r>
+              <a:rPr dirty="0"/>
+              <a:t/>
+            </a:r>
+            <a:r>
+              <a:rPr dirty="0" err="1"/>
+              <a:t/>
+            </a:r>
+            <a:r>
+              <a:rPr dirty="0"/>
+              <a:t/>
+            </a:r>
+          </a:p>
+          <a:p>
+            <a:r>
+              <a:rPr dirty="0"/>
+              <a:t>But look back at the previous slide. All three lost roughly the same amount of accuracy.</a:t>
+            </a:r>
+            <a:r>
+              <a:rPr dirty="0" err="1"/>
+              <a:t/>
+            </a:r>
+            <a:r>
+              <a:rPr dirty="0"/>
+              <a:t/>
+            </a:r>
+            <a:r>
+              <a:rPr dirty="0" err="1"/>
+              <a:t/>
+            </a:r>
+            <a:r>
+              <a:rPr dirty="0"/>
+              <a:t/>
+            </a:r>
+          </a:p>
+          <a:p>
+            <a:r>
+              <a:rPr dirty="0"/>
+              <a:t>So we have architectures with similar accuracy and completely different internal states. Accuracy is not telling us what happened inside the model. This is the point where a study that reported accuracy alone would have to stop.</a:t>
+            </a:r>
+            <a:r>
+              <a:rPr dirty="0" err="1"/>
+              <a:t/>
+            </a:r>
+            <a:r>
+              <a:rPr dirty="0"/>
+              <a:t/>
+            </a:r>
+            <a:r>
+              <a:rPr dirty="0" err="1"/>
+              <a:t/>
+            </a:r>
+            <a:r>
+              <a:rPr dirty="0"/>
+              <a:t/>
             </a:r>
           </a:p>
           <a:p>

</xml_diff>

<commit_message>
project submitted. over and out
</commit_message>
<xml_diff>
--- a/report/CSE705_Cora_GNN.pptx
+++ b/report/CSE705_Cora_GNN.pptx
@@ -961,7 +961,15 @@
           <a:p>
             <a:r>
               <a:rPr dirty="0"/>
-              <a:t>The question is which line. Its top singular vector matches the constant direction with cosine one point zero zero zero zero. Against the square root of degree direction it is zero point nine five.</a:t>
+              <a:t>The question is which line. Its top singular vector matches the constant direction with cosine </a:t>
+            </a:r>
+            <a:r>
+              <a:rPr lang="en-US" dirty="0"/>
+              <a:t>ONE</a:t>
+            </a:r>
+            <a:r>
+              <a:rPr dirty="0"/>
+              <a:t>. Against the square root of degree direction it is zero point nine five.</a:t>
             </a:r>
           </a:p>
           <a:p>
@@ -1484,15 +1492,44 @@
             </a:r>
           </a:p>
           <a:p>
+            <a:pPr marL="0" marR="0" lvl="0" indent="0" algn="l" defTabSz="914400" rtl="0" eaLnBrk="1" fontAlgn="auto" latinLnBrk="0" hangingPunct="1">
+              <a:lnSpc>
+                <a:spcPct val="100000"/>
+              </a:lnSpc>
+              <a:spcBef>
+                <a:spcPts val="0"/>
+              </a:spcBef>
+              <a:spcAft>
+                <a:spcPts val="0"/>
+              </a:spcAft>
+              <a:buClrTx/>
+              <a:buSzTx/>
+              <a:buFontTx/>
+              <a:buNone/>
+              <a:tabLst/>
+              <a:defRPr/>
+            </a:pPr>
             <a:r>
               <a:rPr dirty="0"/>
-              <a:t>Its contraction slope also stays flat, within roughly plus or minus zero point four at every depth, where GCN's runs from about plus one point six to plus two point five.</a:t>
+              <a:t>This is consistent with the idea that preserving </a:t>
+            </a:r>
+            <a:r>
+              <a:rPr dirty="0" err="1"/>
+              <a:t>in</a:t>
+            </a:r>
+            <a:r>
+              <a:rPr lang="en-US" dirty="0" err="1"/>
+              <a:t>Its</a:t>
+            </a:r>
+            <a:r>
+              <a:rPr lang="en-US" dirty="0"/>
+              <a:t> contraction slope also stays flat, within roughly plus or minus zero point four at every depth, where GCN's runs from about plus one point six to plus two point five.</a:t>
             </a:r>
           </a:p>
           <a:p>
             <a:r>
               <a:rPr dirty="0"/>
-              <a:t>This is consistent with the idea that preserving information across layers is what makes depth usable. I want to say clearly that it is consistent with, and not proof of. We did not inspect GCNII's own gradients.</a:t>
+              <a:t>formation across layers is what makes depth usable. I want to say clearly that it is consistent with, and not proof of. We did not inspect GCNII's own gradients.</a:t>
             </a:r>
           </a:p>
           <a:p>
@@ -1579,16 +1616,12 @@
           <a:p>
             <a:r>
               <a:rPr dirty="0"/>
-              <a:t>PRESENTER: Kiarash  </a:t>
-            </a:r>
-            <a:r>
-              <a:t>·  clos</a:t>
-            </a:r>
-            <a:r>
-              <a:rPr lang="en-US"/>
+              <a:t>PRESENTER: Kiarash  ·  clos</a:t>
+            </a:r>
+            <a:r>
+              <a:rPr lang="en-US" dirty="0"/>
               <a:t>ing</a:t>
             </a:r>
-            <a:endParaRPr lang="en-US" dirty="0"/>
           </a:p>
           <a:p>
             <a:endParaRPr dirty="0"/>
@@ -1619,8 +1652,44 @@
           </a:p>
           <a:p>
             <a:r>
+              <a:rPr lang="en-US" dirty="0"/>
+              <a:t>And </a:t>
+            </a:r>
+            <a:r>
               <a:rPr dirty="0"/>
-              <a:t>On scope, this is one dataset, one split, and ten seeds. We do not claim a universal depth limit. What we think transfers is the method, not the numbers.</a:t>
+              <a:t>this </a:t>
+            </a:r>
+            <a:r>
+              <a:rPr lang="en-US" dirty="0"/>
+              <a:t>was just</a:t>
+            </a:r>
+            <a:r>
+              <a:rPr dirty="0"/>
+              <a:t> one dataset</a:t>
+            </a:r>
+            <a:r>
+              <a:rPr lang="en-US" dirty="0"/>
+              <a:t> and learning configuration and cannot be simply generalized.</a:t>
+            </a:r>
+            <a:r>
+              <a:rPr dirty="0"/>
+              <a:t> </a:t>
+            </a:r>
+            <a:r>
+              <a:rPr lang="en-US" dirty="0"/>
+              <a:t> But what </a:t>
+            </a:r>
+            <a:r>
+              <a:rPr dirty="0"/>
+              <a:t>we think </a:t>
+            </a:r>
+            <a:r>
+              <a:rPr lang="en-US" dirty="0"/>
+              <a:t>is that what </a:t>
+            </a:r>
+            <a:r>
+              <a:rPr dirty="0"/>
+              <a:t>transfers is the method, not the numbers.</a:t>
             </a:r>
           </a:p>
           <a:p>
@@ -1752,7 +1821,15 @@
           <a:p>
             <a:r>
               <a:rPr dirty="0"/>
-              <a:t>The panel on the left illustrates that on a small social network, with an untrained model at one through five layers. Watch the shape rather than the colors. At one layer the points fill the box; by four layers they have collapsed onto almost a single line.</a:t>
+              <a:t>The panel on the </a:t>
+            </a:r>
+            <a:r>
+              <a:rPr lang="en-US" dirty="0"/>
+              <a:t>right</a:t>
+            </a:r>
+            <a:r>
+              <a:rPr dirty="0"/>
+              <a:t> illustrates that on a small social network, with an untrained model at one through five layers. Watch the shape rather than the colors. At one layer the points fill the box; by four layers they have collapsed onto almost a single line.</a:t>
             </a:r>
           </a:p>
           <a:p>
@@ -3251,7 +3328,7 @@
               </a:defRPr>
             </a:pPr>
             <a:r>
-              <a:rPr sz="5850" b="1">
+              <a:rPr sz="5850" b="1" dirty="0">
                 <a:solidFill>
                   <a:srgbClr val="F8FAFC"/>
                 </a:solidFill>
@@ -3275,7 +3352,7 @@
               </a:defRPr>
             </a:pPr>
             <a:r>
-              <a:rPr sz="5850" b="1">
+              <a:rPr sz="5850" b="1" dirty="0">
                 <a:solidFill>
                   <a:srgbClr val="F8FAFC"/>
                 </a:solidFill>
@@ -3283,8 +3360,27 @@
                 <a:ea typeface="Arial"/>
                 <a:cs typeface="Arial"/>
               </a:rPr>
-              <a:t>deep GNN oversmoothing</a:t>
-            </a:r>
+              <a:t>deep GNN </a:t>
+            </a:r>
+            <a:r>
+              <a:rPr sz="5850" b="1" dirty="0" err="1">
+                <a:solidFill>
+                  <a:srgbClr val="F8FAFC"/>
+                </a:solidFill>
+                <a:latin typeface="Arial"/>
+                <a:ea typeface="Arial"/>
+                <a:cs typeface="Arial"/>
+              </a:rPr>
+              <a:t>oversmoothing</a:t>
+            </a:r>
+            <a:endParaRPr sz="5850" b="1" dirty="0">
+              <a:solidFill>
+                <a:srgbClr val="F8FAFC"/>
+              </a:solidFill>
+              <a:latin typeface="Arial"/>
+              <a:ea typeface="Arial"/>
+              <a:cs typeface="Arial"/>
+            </a:endParaRPr>
           </a:p>
         </p:txBody>
       </p:sp>

</xml_diff>